<commit_message>
Serve precomputed recs from JSON to slash runtime memory
Existing-user recommendations are now precomputed offline (precompute.py ->
precomputed_recs.json, committed) and served by lookup, so the server never
fits the heavy CF/SVD models at runtime. Cold start runs live but only ever
uses the lightweight content-based model.

- server.py: read PRECOMP json for existing users; lazy single content model
  for cold start; enrich from a movieId->title/genres lookup
- recommenders.py: explain() accepts user_ratings (cold-start why)
- index.html: cold start locks the model to Content-based
Peak RSS: ~610MB -> ~247MB (measured, all methods + cold start).
</commit_message>
<xml_diff>
--- a/slide deck RecSys.pptx
+++ b/slide deck RecSys.pptx
@@ -14284,8 +14284,8 @@
         </p:nvSpPr>
         <p:spPr>
           <a:xfrm>
-            <a:off x="1333500" y="8679180"/>
-            <a:ext cx="5650992" cy="403860"/>
+            <a:off x="7734299" y="8743949"/>
+            <a:ext cx="8845217" cy="1446797"/>
           </a:xfrm>
           <a:prstGeom prst="rect">
             <a:avLst/>
@@ -14295,15 +14295,14 @@
         </p:spPr>
         <p:txBody>
           <a:bodyPr wrap="square" lIns="25400" tIns="25400" rIns="25400" bIns="25400" rtlCol="0" anchor="t">
-            <a:normAutofit fontScale="92500" lnSpcReduction="20000"/>
-          </a:bodyPr>
-          <a:lstStyle/>
-          <a:p>
-            <a:pPr marL="0" indent="0" algn="l">
+            <a:normAutofit fontScale="85000" lnSpcReduction="10000"/>
+          </a:bodyPr>
+          <a:lstStyle/>
+          <a:p>
+            <a:pPr>
               <a:lnSpc>
                 <a:spcPct val="160000"/>
               </a:lnSpc>
-              <a:buNone/>
             </a:pPr>
             <a:r>
               <a:rPr lang="en-US" sz="1800" dirty="0">
@@ -14314,9 +14313,47 @@
                 <a:ea typeface="Courier New" pitchFamily="34" charset="-122"/>
                 <a:cs typeface="Courier New" pitchFamily="34" charset="-120"/>
               </a:rPr>
+              <a:t>It is slower because it is deployed on render and it might fail sometimes because of memory constraint, so it’s better to run it locally.</a:t>
+            </a:r>
+          </a:p>
+          <a:p>
+            <a:pPr>
+              <a:lnSpc>
+                <a:spcPct val="160000"/>
+              </a:lnSpc>
+            </a:pPr>
+            <a:r>
+              <a:rPr lang="en-US" sz="1800" dirty="0">
+                <a:solidFill>
+                  <a:srgbClr val="3A372F"/>
+                </a:solidFill>
+                <a:latin typeface="Courier New" pitchFamily="34" charset="0"/>
+                <a:ea typeface="Courier New" pitchFamily="34" charset="-122"/>
+                <a:cs typeface="Courier New" pitchFamily="34" charset="-120"/>
+              </a:rPr>
               <a:t>Live demo:</a:t>
             </a:r>
-            <a:endParaRPr lang="en-US" sz="1800" dirty="0"/>
+            <a:r>
+              <a:rPr lang="en-US" dirty="0">
+                <a:solidFill>
+                  <a:srgbClr val="3A372F"/>
+                </a:solidFill>
+                <a:latin typeface="Courier New" pitchFamily="34" charset="0"/>
+                <a:ea typeface="Courier New" pitchFamily="34" charset="-122"/>
+                <a:cs typeface="Courier New" pitchFamily="34" charset="-120"/>
+              </a:rPr>
+              <a:t> </a:t>
+            </a:r>
+            <a:r>
+              <a:rPr lang="en-US" sz="2400" dirty="0">
+                <a:solidFill>
+                  <a:srgbClr val="2F6F75"/>
+                </a:solidFill>
+                <a:latin typeface="Courier New" pitchFamily="34" charset="0"/>
+                <a:cs typeface="Courier New" pitchFamily="34" charset="-120"/>
+              </a:rPr>
+              <a:t>https://cinema-recommender-s23s.onrender.com</a:t>
+            </a:r>
           </a:p>
         </p:txBody>
       </p:sp>
@@ -14328,7 +14365,7 @@
         </p:nvSpPr>
         <p:spPr>
           <a:xfrm>
-            <a:off x="1333500" y="9044940"/>
+            <a:off x="1514837" y="9041131"/>
             <a:ext cx="5650992" cy="403860"/>
           </a:xfrm>
           <a:prstGeom prst="rect">

</xml_diff>